<commit_message>
Preenche a equipe e corrige inconsistências da versão refeita
- Equipe (Cauã Marinho, João Ferraz, Guilherme Loiola e Davi Araújo) no
  documento .md e .pdf (capa), no campo Decisores das ADRs 0001 a 0010,
  na capa da apresentação e no README.
- Documento passa à versão 1.1 (20/10/2026).
- Seção 13 do documento dizia que o protótipo das telas ainda seria
  feito; agora aponta para entregas/veridit-telas.pdf (14 telas).
- Slide 16 listava "Protótipo das telas no Figma" como próximo passo;
  trocado, pois o protótipo já existe.
- Registro de IA deixa claro que as ADR-001 a ADR-009 citadas nele são
  da versão anterior e não correspondem às ADRs atuais.

Co-Authored-By: Claude Opus 5.5 <noreply@anthropic.com>
Claude-Session: https://claude.ai/code/session_01VDcu7sn9T4NKi6FjvsXhQB
</commit_message>
<xml_diff>
--- a/entregas/veridit-apresentacao-arquitetura.pptx
+++ b/entregas/veridit-apresentacao-arquitetura.pptx
@@ -2800,6 +2800,42 @@
       </p:sp>
       <p:sp>
         <p:nvSpPr>
+          <p:cNvPr id="4" name="equipe da capa"/>
+          <p:cNvSpPr txBox="1"/>
+          <p:nvPr/>
+        </p:nvSpPr>
+        <p:spPr>
+          <a:xfrm>
+            <a:off x="731520" y="4343400"/>
+            <a:ext cx="10698480" cy="457200"/>
+          </a:xfrm>
+          <a:prstGeom prst="rect">
+            <a:avLst/>
+          </a:prstGeom>
+          <a:noFill/>
+          <a:ln/>
+        </p:spPr>
+        <p:txBody>
+          <a:bodyPr wrap="square" lIns="0" tIns="0" rIns="0" bIns="0" rtlCol="0" anchor="ctr"/>
+          <a:lstStyle/>
+          <a:p>
+            <a:pPr indent="0" marL="0">
+              <a:buNone/>
+            </a:pPr>
+            <a:r>
+              <a:rPr lang="en-US" sz="1600" dirty="0">
+                <a:solidFill>
+                  <a:schemeClr val="bg1"/>
+                </a:solidFill>
+              </a:rPr>
+              <a:t>Equipe: Cauã Marinho, João Ferraz, Guilherme Loiola e Davi Araújo</a:t>
+            </a:r>
+            <a:endParaRPr lang="en-US" sz="1400" dirty="0"/>
+          </a:p>
+        </p:txBody>
+      </p:sp>
+      <p:sp>
+        <p:nvSpPr>
           <p:cNvPr id="5" name="selo círculo"/>
           <p:cNvSpPr/>
           <p:nvPr/>
@@ -6982,7 +7018,7 @@
                   <a:schemeClr val="bg1"/>
                 </a:solidFill>
               </a:rPr>
-              <a:t>Protótipo das telas no Figma</a:t>
+              <a:t>Testar o protótipo das 14 telas com usuários</a:t>
             </a:r>
             <a:endParaRPr lang="en-US" sz="1600" dirty="0"/>
           </a:p>

</xml_diff>